<commit_message>
Unclip the X-CLIP baseline label, and match the chart to the figure
The annotation on the macro-F1 progression sat at the right-hand end,
where it landed on top of the 0.4298 printed above the final bar: both
strings overlapped and the "(0.3881)" was cut to "81)". Moved over the
first bar, where the space above 0.2975 is empty.

The PowerPoint copy of the same figure now carries the two colours the
report uses -- ViT-L features and the final configuration stand out from
the grey run -- and the baseline as a shape. A reference line has no
native object and a second series would need a combination chart, so it
is placed from the axis scale with the value axis pinned to 0-0.5;
measured against the render it lands on 0.3881.

Co-Authored-By: Claude Opus 5 <noreply@anthropic.com>
Claude-Session: https://claude.ai/code/session_01LTN1ToAz7S67GVeppJLK8m
</commit_message>
<xml_diff>
--- a/thesis/Thesis_Figures_Editable.pptx
+++ b/thesis/Thesis_Figures_Editable.pptx
@@ -118,7 +118,7 @@
 <c:chartSpace xmlns:c="http://schemas.openxmlformats.org/drawingml/2006/chart" xmlns:a="http://schemas.openxmlformats.org/drawingml/2006/main" xmlns:r="http://schemas.openxmlformats.org/officeDocument/2006/relationships">
   <c:date1904 val="0"/>
   <c:chart>
-    <c:autoTitleDeleted val="0"/>
+    <c:autoTitleDeleted val="1"/>
     <c:plotArea>
       <c:barChart>
         <c:barDir val="col"/>
@@ -139,9 +139,25 @@
           </c:tx>
           <c:spPr>
             <a:solidFill>
-              <a:srgbClr val="2E5E8C"/>
+              <a:srgbClr val="6A748C"/>
             </a:solidFill>
           </c:spPr>
+          <c:dPt>
+            <c:idx val="3"/>
+            <c:spPr>
+              <a:solidFill>
+                <a:srgbClr val="2E5E8C"/>
+              </a:solidFill>
+            </c:spPr>
+          </c:dPt>
+          <c:dPt>
+            <c:idx val="4"/>
+            <c:spPr>
+              <a:solidFill>
+                <a:srgbClr val="C16B2E"/>
+              </a:solidFill>
+            </c:spPr>
+          </c:dPt>
           <c:cat>
             <c:strRef>
               <c:f>Sheet1!$A$2:$A$6</c:f>
@@ -249,7 +265,10 @@
       </c:catAx>
       <c:valAx>
         <c:axId val="-2113994440"/>
-        <c:scaling/>
+        <c:scaling>
+          <c:max val="0.5"/>
+          <c:min val="0.0"/>
+        </c:scaling>
         <c:delete val="0"/>
         <c:axPos val="l"/>
         <c:majorGridlines/>
@@ -295,7 +314,7 @@
 <c:chartSpace xmlns:c="http://schemas.openxmlformats.org/drawingml/2006/chart" xmlns:a="http://schemas.openxmlformats.org/drawingml/2006/main" xmlns:r="http://schemas.openxmlformats.org/officeDocument/2006/relationships">
   <c:date1904 val="0"/>
   <c:chart>
-    <c:autoTitleDeleted val="0"/>
+    <c:autoTitleDeleted val="1"/>
     <c:plotArea>
       <c:barChart>
         <c:barDir val="col"/>
@@ -601,7 +620,7 @@
 <c:chartSpace xmlns:c="http://schemas.openxmlformats.org/drawingml/2006/chart" xmlns:a="http://schemas.openxmlformats.org/drawingml/2006/main" xmlns:r="http://schemas.openxmlformats.org/officeDocument/2006/relationships">
   <c:date1904 val="0"/>
   <c:chart>
-    <c:autoTitleDeleted val="0"/>
+    <c:autoTitleDeleted val="1"/>
     <c:plotArea>
       <c:barChart>
         <c:barDir val="bar"/>
@@ -813,7 +832,7 @@
 <c:chartSpace xmlns:c="http://schemas.openxmlformats.org/drawingml/2006/chart" xmlns:a="http://schemas.openxmlformats.org/drawingml/2006/main" xmlns:r="http://schemas.openxmlformats.org/officeDocument/2006/relationships">
   <c:date1904 val="0"/>
   <c:chart>
-    <c:autoTitleDeleted val="0"/>
+    <c:autoTitleDeleted val="1"/>
     <c:plotArea>
       <c:barChart>
         <c:barDir val="col"/>
@@ -1070,7 +1089,7 @@
 <c:chartSpace xmlns:c="http://schemas.openxmlformats.org/drawingml/2006/chart" xmlns:a="http://schemas.openxmlformats.org/drawingml/2006/main" xmlns:r="http://schemas.openxmlformats.org/officeDocument/2006/relationships">
   <c:date1904 val="0"/>
   <c:chart>
-    <c:autoTitleDeleted val="0"/>
+    <c:autoTitleDeleted val="1"/>
     <c:plotArea>
       <c:barChart>
         <c:barDir val="bar"/>
@@ -1306,7 +1325,7 @@
 <c:chartSpace xmlns:c="http://schemas.openxmlformats.org/drawingml/2006/chart" xmlns:a="http://schemas.openxmlformats.org/drawingml/2006/main" xmlns:r="http://schemas.openxmlformats.org/officeDocument/2006/relationships">
   <c:date1904 val="0"/>
   <c:chart>
-    <c:autoTitleDeleted val="0"/>
+    <c:autoTitleDeleted val="1"/>
     <c:plotArea>
       <c:lineChart>
         <c:grouping val="standard"/>
@@ -6337,7 +6356,7 @@
         </p:nvGraphicFramePr>
         <p:xfrm>
           <a:off x="822960" y="1097280"/>
-          <a:ext cx="10515600" cy="4480560"/>
+          <a:ext cx="10515600" cy="4206240"/>
         </p:xfrm>
         <a:graphic>
           <a:graphicData uri="http://schemas.openxmlformats.org/drawingml/2006/chart">
@@ -6347,14 +6366,58 @@
       </p:graphicFrame>
       <p:sp>
         <p:nvSpPr>
-          <p:cNvPr id="4" name="TextBox 3"/>
+          <p:cNvPr id="4" name="Rectangle 3"/>
+          <p:cNvSpPr/>
+          <p:nvPr/>
+        </p:nvSpPr>
+        <p:spPr>
+          <a:xfrm>
+            <a:off x="1234440" y="2081364"/>
+            <a:ext cx="9966960" cy="15875"/>
+          </a:xfrm>
+          <a:prstGeom prst="rect">
+            <a:avLst/>
+          </a:prstGeom>
+          <a:solidFill>
+            <a:srgbClr val="C16B2E"/>
+          </a:solidFill>
+          <a:ln>
+            <a:noFill/>
+          </a:ln>
+          <a:effectLst/>
+        </p:spPr>
+        <p:style>
+          <a:lnRef idx="1">
+            <a:schemeClr val="accent1"/>
+          </a:lnRef>
+          <a:fillRef idx="3">
+            <a:schemeClr val="accent1"/>
+          </a:fillRef>
+          <a:effectRef idx="2">
+            <a:schemeClr val="accent1"/>
+          </a:effectRef>
+          <a:fontRef idx="minor">
+            <a:schemeClr val="lt1"/>
+          </a:fontRef>
+        </p:style>
+        <p:txBody>
+          <a:bodyPr rtlCol="0" anchor="ctr"/>
+          <a:lstStyle/>
+          <a:p>
+            <a:pPr algn="ctr"/>
+          </a:p>
+        </p:txBody>
+      </p:sp>
+      <p:sp>
+        <p:nvSpPr>
+          <p:cNvPr id="5" name="TextBox 4"/>
           <p:cNvSpPr txBox="1"/>
           <p:nvPr/>
         </p:nvSpPr>
         <p:spPr>
           <a:xfrm>
-            <a:off x="822960" y="5715000"/>
-            <a:ext cx="10515600" cy="274320"/>
+            <a:off x="1325880" y="1770468"/>
+            <a:ext cx="4572000" cy="274320"/>
           </a:xfrm>
           <a:prstGeom prst="rect">
             <a:avLst/>
@@ -6367,15 +6430,15 @@
           </a:bodyPr>
           <a:lstStyle/>
           <a:p>
-            <a:pPr algn="ctr"/>
-            <a:r>
-              <a:rPr sz="1000" i="1">
+            <a:pPr algn="l"/>
+            <a:r>
+              <a:rPr sz="1000" i="0">
                 <a:solidFill>
                   <a:srgbClr val="C16B2E"/>
                 </a:solidFill>
                 <a:latin typeface="Calibri"/>
               </a:rPr>
-              <a:t>X-CLIP fine-tuned reached 0.3881 on its own split</a:t>
+              <a:t>X-CLIP fine-tuned  0.3881</a:t>
             </a:r>
           </a:p>
         </p:txBody>

</xml_diff>